<commit_message>
Switch PPTX to Arial font, add glassmorphism client follow-up HTML with CTA
https://claude.ai/code/session_01N82xafLtqjjtthd2mE6vJS
</commit_message>
<xml_diff>
--- a/presentation/Bitrix24_KEDO_Smart_Business.pptx
+++ b/presentation/Bitrix24_KEDO_Smart_Business.pptx
@@ -3400,7 +3400,7 @@
                 <a:solidFill>
                   <a:srgbClr val="FFFFFF"/>
                 </a:solidFill>
-                <a:latin typeface="Segoe UI"/>
+                <a:latin typeface="Arial"/>
               </a:rPr>
               <a:t>S</a:t>
             </a:r>
@@ -3442,7 +3442,7 @@
                 <a:solidFill>
                   <a:srgbClr val="FFFFFF"/>
                 </a:solidFill>
-                <a:latin typeface="Segoe UI"/>
+                <a:latin typeface="Arial"/>
               </a:rPr>
               <a:t>smart </a:t>
             </a:r>
@@ -3484,7 +3484,7 @@
                 <a:solidFill>
                   <a:srgbClr val="2FC6F5"/>
                 </a:solidFill>
-                <a:latin typeface="Segoe UI"/>
+                <a:latin typeface="Arial"/>
               </a:rPr>
               <a:t>business</a:t>
             </a:r>
@@ -3526,7 +3526,7 @@
                 <a:solidFill>
                   <a:srgbClr val="FFFFFF"/>
                 </a:solidFill>
-                <a:latin typeface="Segoe UI"/>
+                <a:latin typeface="Arial"/>
               </a:rPr>
               <a:t>Битрикс24 </a:t>
             </a:r>
@@ -3568,7 +3568,7 @@
                 <a:solidFill>
                   <a:srgbClr val="2FC6F5"/>
                 </a:solidFill>
-                <a:latin typeface="Segoe UI"/>
+                <a:latin typeface="Arial"/>
               </a:rPr>
               <a:t>КЭДО</a:t>
             </a:r>
@@ -3610,7 +3610,7 @@
                 <a:solidFill>
                   <a:srgbClr val="FFFFFF"/>
                 </a:solidFill>
-                <a:latin typeface="Segoe UI"/>
+                <a:latin typeface="Arial"/>
               </a:rPr>
               <a:t>Кадровый электронный документооборот с Госключом:</a:t>
             </a:r>
@@ -3629,7 +3629,7 @@
                 <a:solidFill>
                   <a:srgbClr val="B9C9DE"/>
                 </a:solidFill>
-                <a:latin typeface="Segoe UI"/>
+                <a:latin typeface="Arial"/>
               </a:rPr>
               <a:t>документы подписываются за минуты — без бумаги, печати и курьеров</a:t>
             </a:r>
@@ -3717,7 +3717,7 @@
                 <a:solidFill>
                   <a:srgbClr val="FFFFFF"/>
                 </a:solidFill>
-                <a:latin typeface="Segoe UI"/>
+                <a:latin typeface="Arial"/>
               </a:rPr>
               <a:t>Официальный партнёр Битрикс24</a:t>
             </a:r>
@@ -3759,7 +3759,7 @@
                 <a:solidFill>
                   <a:srgbClr val="B9C9DE"/>
                 </a:solidFill>
-                <a:latin typeface="Segoe UI"/>
+                <a:latin typeface="Arial"/>
               </a:rPr>
               <a:t>Smart Business  •  внедрение, настройка и сопровождение Битрикс24</a:t>
             </a:r>
@@ -3907,7 +3907,7 @@
                 <a:solidFill>
                   <a:srgbClr val="1E2A38"/>
                 </a:solidFill>
-                <a:latin typeface="Segoe UI"/>
+                <a:latin typeface="Arial"/>
               </a:rPr>
               <a:t>Как перейти на КЭДО: 5 шагов</a:t>
             </a:r>
@@ -3949,7 +3949,7 @@
                 <a:solidFill>
                   <a:srgbClr val="535C69"/>
                 </a:solidFill>
-                <a:latin typeface="Segoe UI"/>
+                <a:latin typeface="Arial"/>
               </a:rPr>
               <a:t>Юридическая подготовка + настройка Битрикс24 — обычно 2–4 недели</a:t>
             </a:r>
@@ -4037,7 +4037,7 @@
                 <a:solidFill>
                   <a:srgbClr val="FFFFFF"/>
                 </a:solidFill>
-                <a:latin typeface="Segoe UI"/>
+                <a:latin typeface="Arial"/>
               </a:rPr>
               <a:t>S</a:t>
             </a:r>
@@ -4079,7 +4079,7 @@
                 <a:solidFill>
                   <a:srgbClr val="1E2A38"/>
                 </a:solidFill>
-                <a:latin typeface="Segoe UI"/>
+                <a:latin typeface="Arial"/>
               </a:rPr>
               <a:t>smart </a:t>
             </a:r>
@@ -4121,7 +4121,7 @@
                 <a:solidFill>
                   <a:srgbClr val="2FC6F5"/>
                 </a:solidFill>
-                <a:latin typeface="Segoe UI"/>
+                <a:latin typeface="Arial"/>
               </a:rPr>
               <a:t>business</a:t>
             </a:r>
@@ -4163,7 +4163,7 @@
                 <a:solidFill>
                   <a:srgbClr val="535C69"/>
                 </a:solidFill>
-                <a:latin typeface="Segoe UI"/>
+                <a:latin typeface="Arial"/>
               </a:rPr>
               <a:t>10</a:t>
             </a:r>
@@ -4205,7 +4205,7 @@
                 <a:solidFill>
                   <a:srgbClr val="535C69"/>
                 </a:solidFill>
-                <a:latin typeface="Segoe UI"/>
+                <a:latin typeface="Arial"/>
               </a:rPr>
               <a:t>Битрикс24 КЭДО  •  Smart Business — официальный партнёр Битрикс24</a:t>
             </a:r>
@@ -4337,7 +4337,7 @@
                 <a:solidFill>
                   <a:srgbClr val="FFFFFF"/>
                 </a:solidFill>
-                <a:latin typeface="Segoe UI"/>
+                <a:latin typeface="Arial"/>
               </a:rPr>
               <a:t>1</a:t>
             </a:r>
@@ -4379,7 +4379,7 @@
                 <a:solidFill>
                   <a:srgbClr val="1E2A38"/>
                 </a:solidFill>
-                <a:latin typeface="Segoe UI"/>
+                <a:latin typeface="Arial"/>
               </a:rPr>
               <a:t>Локальный нормативный акт</a:t>
             </a:r>
@@ -4421,7 +4421,7 @@
                 <a:solidFill>
                   <a:srgbClr val="535C69"/>
                 </a:solidFill>
-                <a:latin typeface="Segoe UI"/>
+                <a:latin typeface="Arial"/>
               </a:rPr>
               <a:t>Утвердите положение о КЭДО: система, порядок доступа, перечень документов и сроки.</a:t>
             </a:r>
@@ -4553,7 +4553,7 @@
                 <a:solidFill>
                   <a:srgbClr val="FFFFFF"/>
                 </a:solidFill>
-                <a:latin typeface="Segoe UI"/>
+                <a:latin typeface="Arial"/>
               </a:rPr>
               <a:t>2</a:t>
             </a:r>
@@ -4595,7 +4595,7 @@
                 <a:solidFill>
                   <a:srgbClr val="1E2A38"/>
                 </a:solidFill>
-                <a:latin typeface="Segoe UI"/>
+                <a:latin typeface="Arial"/>
               </a:rPr>
               <a:t>Уведомление сотрудников</a:t>
             </a:r>
@@ -4637,7 +4637,7 @@
                 <a:solidFill>
                   <a:srgbClr val="535C69"/>
                 </a:solidFill>
-                <a:latin typeface="Segoe UI"/>
+                <a:latin typeface="Arial"/>
               </a:rPr>
               <a:t>Закон требует уведомить персонал о переходе на электронный документооборот до запуска.</a:t>
             </a:r>
@@ -4769,7 +4769,7 @@
                 <a:solidFill>
                   <a:srgbClr val="FFFFFF"/>
                 </a:solidFill>
-                <a:latin typeface="Segoe UI"/>
+                <a:latin typeface="Arial"/>
               </a:rPr>
               <a:t>3</a:t>
             </a:r>
@@ -4811,7 +4811,7 @@
                 <a:solidFill>
                   <a:srgbClr val="1E2A38"/>
                 </a:solidFill>
-                <a:latin typeface="Segoe UI"/>
+                <a:latin typeface="Arial"/>
               </a:rPr>
               <a:t>Сбор согласий</a:t>
             </a:r>
@@ -4853,7 +4853,7 @@
                 <a:solidFill>
                   <a:srgbClr val="535C69"/>
                 </a:solidFill>
-                <a:latin typeface="Segoe UI"/>
+                <a:latin typeface="Arial"/>
               </a:rPr>
               <a:t>Получите письменные согласия — удобно собрать их прямо в Битрикс24.</a:t>
             </a:r>
@@ -4985,7 +4985,7 @@
                 <a:solidFill>
                   <a:srgbClr val="FFFFFF"/>
                 </a:solidFill>
-                <a:latin typeface="Segoe UI"/>
+                <a:latin typeface="Arial"/>
               </a:rPr>
               <a:t>4</a:t>
             </a:r>
@@ -5027,7 +5027,7 @@
                 <a:solidFill>
                   <a:srgbClr val="1E2A38"/>
                 </a:solidFill>
-                <a:latin typeface="Segoe UI"/>
+                <a:latin typeface="Arial"/>
               </a:rPr>
               <a:t>Настройка Битрикс24 КЭДО</a:t>
             </a:r>
@@ -5069,7 +5069,7 @@
                 <a:solidFill>
                   <a:srgbClr val="535C69"/>
                 </a:solidFill>
-                <a:latin typeface="Segoe UI"/>
+                <a:latin typeface="Arial"/>
               </a:rPr>
               <a:t>Раздел «КЭДО + Госключ»: компания, представители, шаблоны, маршруты, интеграция с 1С.</a:t>
             </a:r>
@@ -5201,7 +5201,7 @@
                 <a:solidFill>
                   <a:srgbClr val="FFFFFF"/>
                 </a:solidFill>
-                <a:latin typeface="Segoe UI"/>
+                <a:latin typeface="Arial"/>
               </a:rPr>
               <a:t>5</a:t>
             </a:r>
@@ -5243,7 +5243,7 @@
                 <a:solidFill>
                   <a:srgbClr val="1E2A38"/>
                 </a:solidFill>
-                <a:latin typeface="Segoe UI"/>
+                <a:latin typeface="Arial"/>
               </a:rPr>
               <a:t>Запуск и обучение</a:t>
             </a:r>
@@ -5285,7 +5285,7 @@
                 <a:solidFill>
                   <a:srgbClr val="535C69"/>
                 </a:solidFill>
-                <a:latin typeface="Segoe UI"/>
+                <a:latin typeface="Arial"/>
               </a:rPr>
               <a:t>Сотрудники устанавливают Госключ, подписывают первые документы — HR контролирует статусы.</a:t>
             </a:r>
@@ -5373,7 +5373,7 @@
                 <a:solidFill>
                   <a:srgbClr val="2FC6F5"/>
                 </a:solidFill>
-                <a:latin typeface="Segoe UI"/>
+                <a:latin typeface="Arial"/>
               </a:rPr>
               <a:t>Smart Business берёт на себя</a:t>
             </a:r>
@@ -5392,7 +5392,7 @@
                 <a:solidFill>
                   <a:srgbClr val="FFFFFF"/>
                 </a:solidFill>
-                <a:latin typeface="Segoe UI"/>
+                <a:latin typeface="Arial"/>
               </a:rPr>
               <a:t>шаблоны ЛНА, настройку портала, интеграцию с 1С и обучение команды.</a:t>
             </a:r>
@@ -5540,7 +5540,7 @@
                 <a:solidFill>
                   <a:srgbClr val="1E2A38"/>
                 </a:solidFill>
-                <a:latin typeface="Segoe UI"/>
+                <a:latin typeface="Arial"/>
               </a:rPr>
               <a:t>Выгоды и условия подключения</a:t>
             </a:r>
@@ -5628,7 +5628,7 @@
                 <a:solidFill>
                   <a:srgbClr val="FFFFFF"/>
                 </a:solidFill>
-                <a:latin typeface="Segoe UI"/>
+                <a:latin typeface="Arial"/>
               </a:rPr>
               <a:t>S</a:t>
             </a:r>
@@ -5670,7 +5670,7 @@
                 <a:solidFill>
                   <a:srgbClr val="1E2A38"/>
                 </a:solidFill>
-                <a:latin typeface="Segoe UI"/>
+                <a:latin typeface="Arial"/>
               </a:rPr>
               <a:t>smart </a:t>
             </a:r>
@@ -5712,7 +5712,7 @@
                 <a:solidFill>
                   <a:srgbClr val="2FC6F5"/>
                 </a:solidFill>
-                <a:latin typeface="Segoe UI"/>
+                <a:latin typeface="Arial"/>
               </a:rPr>
               <a:t>business</a:t>
             </a:r>
@@ -5754,7 +5754,7 @@
                 <a:solidFill>
                   <a:srgbClr val="535C69"/>
                 </a:solidFill>
-                <a:latin typeface="Segoe UI"/>
+                <a:latin typeface="Arial"/>
               </a:rPr>
               <a:t>11</a:t>
             </a:r>
@@ -5796,7 +5796,7 @@
                 <a:solidFill>
                   <a:srgbClr val="535C69"/>
                 </a:solidFill>
-                <a:latin typeface="Segoe UI"/>
+                <a:latin typeface="Arial"/>
               </a:rPr>
               <a:t>Битрикс24 КЭДО  •  Smart Business — официальный партнёр Битрикс24</a:t>
             </a:r>
@@ -5884,7 +5884,7 @@
                 <a:solidFill>
                   <a:srgbClr val="0075FF"/>
                 </a:solidFill>
-                <a:latin typeface="Segoe UI"/>
+                <a:latin typeface="Arial"/>
               </a:rPr>
               <a:t>−80%</a:t>
             </a:r>
@@ -5926,7 +5926,7 @@
                 <a:solidFill>
                   <a:srgbClr val="535C69"/>
                 </a:solidFill>
-                <a:latin typeface="Segoe UI"/>
+                <a:latin typeface="Arial"/>
               </a:rPr>
               <a:t>времени на согласование и подписание кадровых документов</a:t>
             </a:r>
@@ -6014,7 +6014,7 @@
                 <a:solidFill>
                   <a:srgbClr val="2FC6F5"/>
                 </a:solidFill>
-                <a:latin typeface="Segoe UI"/>
+                <a:latin typeface="Arial"/>
               </a:rPr>
               <a:t>30 ч</a:t>
             </a:r>
@@ -6056,7 +6056,7 @@
                 <a:solidFill>
                   <a:srgbClr val="535C69"/>
                 </a:solidFill>
-                <a:latin typeface="Segoe UI"/>
+                <a:latin typeface="Arial"/>
               </a:rPr>
               <a:t>в месяц экономии для каждого кадрового специалиста</a:t>
             </a:r>
@@ -6144,7 +6144,7 @@
                 <a:solidFill>
                   <a:srgbClr val="9DCF00"/>
                 </a:solidFill>
-                <a:latin typeface="Segoe UI"/>
+                <a:latin typeface="Arial"/>
               </a:rPr>
               <a:t>2 клика</a:t>
             </a:r>
@@ -6186,7 +6186,7 @@
                 <a:solidFill>
                   <a:srgbClr val="535C69"/>
                 </a:solidFill>
-                <a:latin typeface="Segoe UI"/>
+                <a:latin typeface="Arial"/>
               </a:rPr>
               <a:t>— и нужный документ найден в архиве даже через 5 лет</a:t>
             </a:r>
@@ -6274,7 +6274,7 @@
                 <a:solidFill>
                   <a:srgbClr val="F9A91D"/>
                 </a:solidFill>
-                <a:latin typeface="Segoe UI"/>
+                <a:latin typeface="Arial"/>
               </a:rPr>
               <a:t>100%</a:t>
             </a:r>
@@ -6316,7 +6316,7 @@
                 <a:solidFill>
                   <a:srgbClr val="535C69"/>
                 </a:solidFill>
-                <a:latin typeface="Segoe UI"/>
+                <a:latin typeface="Arial"/>
               </a:rPr>
               <a:t>юридическая значимость по 377-ФЗ и ТК РФ</a:t>
             </a:r>
@@ -6404,7 +6404,7 @@
                 <a:solidFill>
                   <a:srgbClr val="1E2A38"/>
                 </a:solidFill>
-                <a:latin typeface="Segoe UI"/>
+                <a:latin typeface="Arial"/>
               </a:rPr>
               <a:t>Условия подключения</a:t>
             </a:r>
@@ -6446,7 +6446,7 @@
                 <a:solidFill>
                   <a:srgbClr val="535C69"/>
                 </a:solidFill>
-                <a:latin typeface="Segoe UI"/>
+                <a:latin typeface="Arial"/>
               </a:rPr>
               <a:t>•  КЭДО входит в тарифы Битрикс24 «Профессиональный» и «Энтерпрайз» — без доплаты за пользователей и количество документов</a:t>
             </a:r>
@@ -6465,7 +6465,7 @@
                 <a:solidFill>
                   <a:srgbClr val="535C69"/>
                 </a:solidFill>
-                <a:latin typeface="Segoe UI"/>
+                <a:latin typeface="Arial"/>
               </a:rPr>
               <a:t>•  Госключ для сотрудников бесплатен; отдельные лицензии на КЭДО покупать не нужно</a:t>
             </a:r>
@@ -6484,7 +6484,7 @@
                 <a:solidFill>
                   <a:srgbClr val="535C69"/>
                 </a:solidFill>
-                <a:latin typeface="Segoe UI"/>
+                <a:latin typeface="Arial"/>
               </a:rPr>
               <a:t>•  Если вы уже на этих тарифах — инструмент достаточно настроить и запустить</a:t>
             </a:r>
@@ -6678,7 +6678,7 @@
                 <a:solidFill>
                   <a:srgbClr val="FFFFFF"/>
                 </a:solidFill>
-                <a:latin typeface="Segoe UI"/>
+                <a:latin typeface="Arial"/>
               </a:rPr>
               <a:t>S</a:t>
             </a:r>
@@ -6720,7 +6720,7 @@
                 <a:solidFill>
                   <a:srgbClr val="FFFFFF"/>
                 </a:solidFill>
-                <a:latin typeface="Segoe UI"/>
+                <a:latin typeface="Arial"/>
               </a:rPr>
               <a:t>smart </a:t>
             </a:r>
@@ -6762,7 +6762,7 @@
                 <a:solidFill>
                   <a:srgbClr val="2FC6F5"/>
                 </a:solidFill>
-                <a:latin typeface="Segoe UI"/>
+                <a:latin typeface="Arial"/>
               </a:rPr>
               <a:t>business</a:t>
             </a:r>
@@ -6804,7 +6804,7 @@
                 <a:solidFill>
                   <a:srgbClr val="FFFFFF"/>
                 </a:solidFill>
-                <a:latin typeface="Segoe UI"/>
+                <a:latin typeface="Arial"/>
               </a:rPr>
               <a:t>Внедрим Битрикс24 КЭДО под ключ</a:t>
             </a:r>
@@ -6846,7 +6846,7 @@
                 <a:solidFill>
                   <a:srgbClr val="B9C9DE"/>
                 </a:solidFill>
-                <a:latin typeface="Segoe UI"/>
+                <a:latin typeface="Arial"/>
               </a:rPr>
               <a:t>Smart Business — официальный партнёр Битрикс24. Ростов-на-Дону, работаем с клиентами по всей России.</a:t>
             </a:r>
@@ -6934,7 +6934,7 @@
                 <a:solidFill>
                   <a:srgbClr val="2FC6F5"/>
                 </a:solidFill>
-                <a:latin typeface="Segoe UI"/>
+                <a:latin typeface="Arial"/>
               </a:rPr>
               <a:t>Аудит и план перехода</a:t>
             </a:r>
@@ -6976,7 +6976,7 @@
                 <a:solidFill>
                   <a:srgbClr val="FFFFFF"/>
                 </a:solidFill>
-                <a:latin typeface="Segoe UI"/>
+                <a:latin typeface="Arial"/>
               </a:rPr>
               <a:t>Анализ кадровых процессов, перечень документов, шаблоны ЛНА и согласий.</a:t>
             </a:r>
@@ -7064,7 +7064,7 @@
                 <a:solidFill>
                   <a:srgbClr val="2FC6F5"/>
                 </a:solidFill>
-                <a:latin typeface="Segoe UI"/>
+                <a:latin typeface="Arial"/>
               </a:rPr>
               <a:t>Настройка и интеграции</a:t>
             </a:r>
@@ -7106,7 +7106,7 @@
                 <a:solidFill>
                   <a:srgbClr val="FFFFFF"/>
                 </a:solidFill>
-                <a:latin typeface="Segoe UI"/>
+                <a:latin typeface="Arial"/>
               </a:rPr>
               <a:t>КЭДО + Госключ, шаблоны и маршруты, интеграция с 1С:ЗУП.</a:t>
             </a:r>
@@ -7194,7 +7194,7 @@
                 <a:solidFill>
                   <a:srgbClr val="2FC6F5"/>
                 </a:solidFill>
-                <a:latin typeface="Segoe UI"/>
+                <a:latin typeface="Arial"/>
               </a:rPr>
               <a:t>Обучение и поддержка</a:t>
             </a:r>
@@ -7236,7 +7236,7 @@
                 <a:solidFill>
                   <a:srgbClr val="FFFFFF"/>
                 </a:solidFill>
-                <a:latin typeface="Segoe UI"/>
+                <a:latin typeface="Arial"/>
               </a:rPr>
               <a:t>Обучение HR и сотрудников, сопровождение после запуска.</a:t>
             </a:r>
@@ -7324,7 +7324,7 @@
                 <a:solidFill>
                   <a:srgbClr val="FFFFFF"/>
                 </a:solidFill>
-                <a:latin typeface="Segoe UI"/>
+                <a:latin typeface="Arial"/>
               </a:rPr>
               <a:t>Запросить демонстрацию КЭДО</a:t>
             </a:r>
@@ -7366,7 +7366,7 @@
                 <a:solidFill>
                   <a:srgbClr val="2FC6F5"/>
                 </a:solidFill>
-                <a:latin typeface="Segoe UI"/>
+                <a:latin typeface="Arial"/>
               </a:rPr>
               <a:t>bitrix24.ru/partners/partner/9471955</a:t>
             </a:r>
@@ -7514,7 +7514,7 @@
                 <a:solidFill>
                   <a:srgbClr val="1E2A38"/>
                 </a:solidFill>
-                <a:latin typeface="Segoe UI"/>
+                <a:latin typeface="Arial"/>
               </a:rPr>
               <a:t>Что такое КЭДО</a:t>
             </a:r>
@@ -7556,7 +7556,7 @@
                 <a:solidFill>
                   <a:srgbClr val="535C69"/>
                 </a:solidFill>
-                <a:latin typeface="Segoe UI"/>
+                <a:latin typeface="Arial"/>
               </a:rPr>
               <a:t>Подписание кадровых документов между компанией и сотрудником онлайн — без бумаги и личных встреч</a:t>
             </a:r>
@@ -7644,7 +7644,7 @@
                 <a:solidFill>
                   <a:srgbClr val="FFFFFF"/>
                 </a:solidFill>
-                <a:latin typeface="Segoe UI"/>
+                <a:latin typeface="Arial"/>
               </a:rPr>
               <a:t>S</a:t>
             </a:r>
@@ -7686,7 +7686,7 @@
                 <a:solidFill>
                   <a:srgbClr val="1E2A38"/>
                 </a:solidFill>
-                <a:latin typeface="Segoe UI"/>
+                <a:latin typeface="Arial"/>
               </a:rPr>
               <a:t>smart </a:t>
             </a:r>
@@ -7728,7 +7728,7 @@
                 <a:solidFill>
                   <a:srgbClr val="2FC6F5"/>
                 </a:solidFill>
-                <a:latin typeface="Segoe UI"/>
+                <a:latin typeface="Arial"/>
               </a:rPr>
               <a:t>business</a:t>
             </a:r>
@@ -7770,7 +7770,7 @@
                 <a:solidFill>
                   <a:srgbClr val="535C69"/>
                 </a:solidFill>
-                <a:latin typeface="Segoe UI"/>
+                <a:latin typeface="Arial"/>
               </a:rPr>
               <a:t>02</a:t>
             </a:r>
@@ -7812,7 +7812,7 @@
                 <a:solidFill>
                   <a:srgbClr val="535C69"/>
                 </a:solidFill>
-                <a:latin typeface="Segoe UI"/>
+                <a:latin typeface="Arial"/>
               </a:rPr>
               <a:t>Битрикс24 КЭДО  •  Smart Business — официальный партнёр Битрикс24</a:t>
             </a:r>
@@ -7944,7 +7944,7 @@
                 <a:solidFill>
                   <a:srgbClr val="1E2A38"/>
                 </a:solidFill>
-                <a:latin typeface="Segoe UI"/>
+                <a:latin typeface="Arial"/>
               </a:rPr>
               <a:t>Полностью юридически значимо</a:t>
             </a:r>
@@ -7986,7 +7986,7 @@
                 <a:solidFill>
                   <a:srgbClr val="535C69"/>
                 </a:solidFill>
-                <a:latin typeface="Segoe UI"/>
+                <a:latin typeface="Arial"/>
               </a:rPr>
               <a:t>Электронные кадровые документы равнозначны бумажным. Правовая база:
 • Федеральный закон № 377-ФЗ от 22.11.2021
@@ -8121,7 +8121,7 @@
                 <a:solidFill>
                   <a:srgbClr val="1E2A38"/>
                 </a:solidFill>
-                <a:latin typeface="Segoe UI"/>
+                <a:latin typeface="Arial"/>
               </a:rPr>
               <a:t>Где находится в Битрикс24</a:t>
             </a:r>
@@ -8163,7 +8163,7 @@
                 <a:solidFill>
                   <a:srgbClr val="535C69"/>
                 </a:solidFill>
-                <a:latin typeface="Segoe UI"/>
+                <a:latin typeface="Arial"/>
               </a:rPr>
               <a:t>Раздел «КЭДО + Госключ» в главном меню портала.
 Сотрудники подписывают документы из браузера или мобильного приложения Битрикс24 — где бы они ни находились: в офисе, на удалёнке или в командировке.</a:t>
@@ -8296,7 +8296,7 @@
                 <a:solidFill>
                   <a:srgbClr val="1E2A38"/>
                 </a:solidFill>
-                <a:latin typeface="Segoe UI"/>
+                <a:latin typeface="Arial"/>
               </a:rPr>
               <a:t>Для кого</a:t>
             </a:r>
@@ -8338,7 +8338,7 @@
                 <a:solidFill>
                   <a:srgbClr val="535C69"/>
                 </a:solidFill>
-                <a:latin typeface="Segoe UI"/>
+                <a:latin typeface="Arial"/>
               </a:rPr>
               <a:t>• Компании с удалёнными сотрудниками и филиалами
 • HR-отделы с большим потоком документов
@@ -8473,7 +8473,7 @@
                 <a:solidFill>
                   <a:srgbClr val="1E2A38"/>
                 </a:solidFill>
-                <a:latin typeface="Segoe UI"/>
+                <a:latin typeface="Arial"/>
               </a:rPr>
               <a:t>Что переводится в электронный вид</a:t>
             </a:r>
@@ -8515,7 +8515,7 @@
                 <a:solidFill>
                   <a:srgbClr val="535C69"/>
                 </a:solidFill>
-                <a:latin typeface="Segoe UI"/>
+                <a:latin typeface="Arial"/>
               </a:rPr>
               <a:t>Трудовые договоры и допсоглашения, приказы, заявления (отпуск, командировка, отгул), согласия на обработку персональных данных, положения и регламенты, ознакомление с ЛНА.</a:t>
             </a:r>
@@ -8663,7 +8663,7 @@
                 <a:solidFill>
                   <a:srgbClr val="1E2A38"/>
                 </a:solidFill>
-                <a:latin typeface="Segoe UI"/>
+                <a:latin typeface="Arial"/>
               </a:rPr>
               <a:t>Почему бумажный кадровый документооборот — это дорого</a:t>
             </a:r>
@@ -8751,7 +8751,7 @@
                 <a:solidFill>
                   <a:srgbClr val="FFFFFF"/>
                 </a:solidFill>
-                <a:latin typeface="Segoe UI"/>
+                <a:latin typeface="Arial"/>
               </a:rPr>
               <a:t>S</a:t>
             </a:r>
@@ -8793,7 +8793,7 @@
                 <a:solidFill>
                   <a:srgbClr val="1E2A38"/>
                 </a:solidFill>
-                <a:latin typeface="Segoe UI"/>
+                <a:latin typeface="Arial"/>
               </a:rPr>
               <a:t>smart </a:t>
             </a:r>
@@ -8835,7 +8835,7 @@
                 <a:solidFill>
                   <a:srgbClr val="2FC6F5"/>
                 </a:solidFill>
-                <a:latin typeface="Segoe UI"/>
+                <a:latin typeface="Arial"/>
               </a:rPr>
               <a:t>business</a:t>
             </a:r>
@@ -8877,7 +8877,7 @@
                 <a:solidFill>
                   <a:srgbClr val="535C69"/>
                 </a:solidFill>
-                <a:latin typeface="Segoe UI"/>
+                <a:latin typeface="Arial"/>
               </a:rPr>
               <a:t>03</a:t>
             </a:r>
@@ -8919,7 +8919,7 @@
                 <a:solidFill>
                   <a:srgbClr val="535C69"/>
                 </a:solidFill>
-                <a:latin typeface="Segoe UI"/>
+                <a:latin typeface="Arial"/>
               </a:rPr>
               <a:t>Битрикс24 КЭДО  •  Smart Business — официальный партнёр Битрикс24</a:t>
             </a:r>
@@ -9005,7 +9005,7 @@
                 <a:solidFill>
                   <a:srgbClr val="1E2A38"/>
                 </a:solidFill>
-                <a:latin typeface="Segoe UI"/>
+                <a:latin typeface="Arial"/>
               </a:rPr>
               <a:t>Долго</a:t>
             </a:r>
@@ -9024,7 +9024,7 @@
                 <a:solidFill>
                   <a:srgbClr val="535C69"/>
                 </a:solidFill>
-                <a:latin typeface="Segoe UI"/>
+                <a:latin typeface="Arial"/>
               </a:rPr>
               <a:t> — подписание с удалённым сотрудником занимает дни: печать, курьер, ожидание, возврат.</a:t>
             </a:r>
@@ -9110,7 +9110,7 @@
                 <a:solidFill>
                   <a:srgbClr val="1E2A38"/>
                 </a:solidFill>
-                <a:latin typeface="Segoe UI"/>
+                <a:latin typeface="Arial"/>
               </a:rPr>
               <a:t>Дорого</a:t>
             </a:r>
@@ -9129,7 +9129,7 @@
                 <a:solidFill>
                   <a:srgbClr val="535C69"/>
                 </a:solidFill>
-                <a:latin typeface="Segoe UI"/>
+                <a:latin typeface="Arial"/>
               </a:rPr>
               <a:t> — бумага, печать, доставка, архивное хранение, время HR.</a:t>
             </a:r>
@@ -9215,7 +9215,7 @@
                 <a:solidFill>
                   <a:srgbClr val="1E2A38"/>
                 </a:solidFill>
-                <a:latin typeface="Segoe UI"/>
+                <a:latin typeface="Arial"/>
               </a:rPr>
               <a:t>Рискованно</a:t>
             </a:r>
@@ -9234,7 +9234,7 @@
                 <a:solidFill>
                   <a:srgbClr val="535C69"/>
                 </a:solidFill>
-                <a:latin typeface="Segoe UI"/>
+                <a:latin typeface="Arial"/>
               </a:rPr>
               <a:t> — документы теряются, подписываются с опозданием или не теми датами.</a:t>
             </a:r>
@@ -9320,7 +9320,7 @@
                 <a:solidFill>
                   <a:srgbClr val="1E2A38"/>
                 </a:solidFill>
-                <a:latin typeface="Segoe UI"/>
+                <a:latin typeface="Arial"/>
               </a:rPr>
               <a:t>Непрозрачно</a:t>
             </a:r>
@@ -9339,7 +9339,7 @@
                 <a:solidFill>
                   <a:srgbClr val="535C69"/>
                 </a:solidFill>
-                <a:latin typeface="Segoe UI"/>
+                <a:latin typeface="Arial"/>
               </a:rPr>
               <a:t> — непонятно, на каком этапе документ и кто его задерживает.</a:t>
             </a:r>
@@ -9427,7 +9427,7 @@
                 <a:solidFill>
                   <a:srgbClr val="0075FF"/>
                 </a:solidFill>
-                <a:latin typeface="Segoe UI"/>
+                <a:latin typeface="Arial"/>
               </a:rPr>
               <a:t>−80%</a:t>
             </a:r>
@@ -9469,7 +9469,7 @@
                 <a:solidFill>
                   <a:srgbClr val="535C69"/>
                 </a:solidFill>
-                <a:latin typeface="Segoe UI"/>
+                <a:latin typeface="Arial"/>
               </a:rPr>
               <a:t>времени HR-отдела на создание, согласование и подписание документов</a:t>
             </a:r>
@@ -9557,7 +9557,7 @@
                 <a:solidFill>
                   <a:srgbClr val="2FC6F5"/>
                 </a:solidFill>
-                <a:latin typeface="Segoe UI"/>
+                <a:latin typeface="Arial"/>
               </a:rPr>
               <a:t>30 ч</a:t>
             </a:r>
@@ -9599,7 +9599,7 @@
                 <a:solidFill>
                   <a:srgbClr val="535C69"/>
                 </a:solidFill>
-                <a:latin typeface="Segoe UI"/>
+                <a:latin typeface="Arial"/>
               </a:rPr>
               <a:t>в месяц экономит кадровый специалист с Битрикс24 КЭДО</a:t>
             </a:r>
@@ -9687,7 +9687,7 @@
                 <a:solidFill>
                   <a:srgbClr val="9DCF00"/>
                 </a:solidFill>
-                <a:latin typeface="Segoe UI"/>
+                <a:latin typeface="Arial"/>
               </a:rPr>
               <a:t>2 мин</a:t>
             </a:r>
@@ -9729,7 +9729,7 @@
                 <a:solidFill>
                   <a:srgbClr val="535C69"/>
                 </a:solidFill>
-                <a:latin typeface="Segoe UI"/>
+                <a:latin typeface="Arial"/>
               </a:rPr>
               <a:t>среднее время подписания документа сотрудником через Госключ</a:t>
             </a:r>
@@ -9817,7 +9817,7 @@
                 <a:solidFill>
                   <a:srgbClr val="F9A91D"/>
                 </a:solidFill>
-                <a:latin typeface="Segoe UI"/>
+                <a:latin typeface="Arial"/>
               </a:rPr>
               <a:t>0 ₽</a:t>
             </a:r>
@@ -9859,7 +9859,7 @@
                 <a:solidFill>
                   <a:srgbClr val="535C69"/>
                 </a:solidFill>
-                <a:latin typeface="Segoe UI"/>
+                <a:latin typeface="Arial"/>
               </a:rPr>
               <a:t>расходов на бумагу, печать, курьеров и физический архив</a:t>
             </a:r>
@@ -10007,7 +10007,7 @@
                 <a:solidFill>
                   <a:srgbClr val="1E2A38"/>
                 </a:solidFill>
-                <a:latin typeface="Segoe UI"/>
+                <a:latin typeface="Arial"/>
               </a:rPr>
               <a:t>Возможности Битрикс24 КЭДО</a:t>
             </a:r>
@@ -10049,7 +10049,7 @@
                 <a:solidFill>
                   <a:srgbClr val="535C69"/>
                 </a:solidFill>
-                <a:latin typeface="Segoe UI"/>
+                <a:latin typeface="Arial"/>
               </a:rPr>
               <a:t>Полный цикл работы с кадровыми документами в одном окне</a:t>
             </a:r>
@@ -10137,7 +10137,7 @@
                 <a:solidFill>
                   <a:srgbClr val="FFFFFF"/>
                 </a:solidFill>
-                <a:latin typeface="Segoe UI"/>
+                <a:latin typeface="Arial"/>
               </a:rPr>
               <a:t>S</a:t>
             </a:r>
@@ -10179,7 +10179,7 @@
                 <a:solidFill>
                   <a:srgbClr val="1E2A38"/>
                 </a:solidFill>
-                <a:latin typeface="Segoe UI"/>
+                <a:latin typeface="Arial"/>
               </a:rPr>
               <a:t>smart </a:t>
             </a:r>
@@ -10221,7 +10221,7 @@
                 <a:solidFill>
                   <a:srgbClr val="2FC6F5"/>
                 </a:solidFill>
-                <a:latin typeface="Segoe UI"/>
+                <a:latin typeface="Arial"/>
               </a:rPr>
               <a:t>business</a:t>
             </a:r>
@@ -10263,7 +10263,7 @@
                 <a:solidFill>
                   <a:srgbClr val="535C69"/>
                 </a:solidFill>
-                <a:latin typeface="Segoe UI"/>
+                <a:latin typeface="Arial"/>
               </a:rPr>
               <a:t>04</a:t>
             </a:r>
@@ -10305,7 +10305,7 @@
                 <a:solidFill>
                   <a:srgbClr val="535C69"/>
                 </a:solidFill>
-                <a:latin typeface="Segoe UI"/>
+                <a:latin typeface="Arial"/>
               </a:rPr>
               <a:t>Битрикс24 КЭДО  •  Smart Business — официальный партнёр Битрикс24</a:t>
             </a:r>
@@ -10437,7 +10437,7 @@
                 <a:solidFill>
                   <a:srgbClr val="1E2A38"/>
                 </a:solidFill>
-                <a:latin typeface="Segoe UI"/>
+                <a:latin typeface="Arial"/>
               </a:rPr>
               <a:t>Шаблоны документов</a:t>
             </a:r>
@@ -10479,7 +10479,7 @@
                 <a:solidFill>
                   <a:srgbClr val="535C69"/>
                 </a:solidFill>
-                <a:latin typeface="Segoe UI"/>
+                <a:latin typeface="Arial"/>
               </a:rPr>
               <a:t>Готовые и собственные шаблоны: данные компании и сотрудника подставляются автоматически из Битрикс24.</a:t>
             </a:r>
@@ -10611,7 +10611,7 @@
                 <a:solidFill>
                   <a:srgbClr val="1E2A38"/>
                 </a:solidFill>
-                <a:latin typeface="Segoe UI"/>
+                <a:latin typeface="Arial"/>
               </a:rPr>
               <a:t>Комплекты документов</a:t>
             </a:r>
@@ -10653,7 +10653,7 @@
                 <a:solidFill>
                   <a:srgbClr val="535C69"/>
                 </a:solidFill>
-                <a:latin typeface="Segoe UI"/>
+                <a:latin typeface="Arial"/>
               </a:rPr>
               <a:t>Наборы для типовых ситуаций: приём сотрудника — трудовой договор, NDA, согласие на обработку ПД одним кликом.</a:t>
             </a:r>
@@ -10785,7 +10785,7 @@
                 <a:solidFill>
                   <a:srgbClr val="1E2A38"/>
                 </a:solidFill>
-                <a:latin typeface="Segoe UI"/>
+                <a:latin typeface="Arial"/>
               </a:rPr>
               <a:t>Маршруты подписания</a:t>
             </a:r>
@@ -10827,7 +10827,7 @@
                 <a:solidFill>
                   <a:srgbClr val="535C69"/>
                 </a:solidFill>
-                <a:latin typeface="Segoe UI"/>
+                <a:latin typeface="Arial"/>
               </a:rPr>
               <a:t>Согласующие по ролям, а не по фамилиям: «руководитель отдела», «директор». Маршрут — от компании или от сотрудника.</a:t>
             </a:r>
@@ -10959,7 +10959,7 @@
                 <a:solidFill>
                   <a:srgbClr val="1E2A38"/>
                 </a:solidFill>
-                <a:latin typeface="Segoe UI"/>
+                <a:latin typeface="Arial"/>
               </a:rPr>
               <a:t>Подписание через Госключ</a:t>
             </a:r>
@@ -11001,7 +11001,7 @@
                 <a:solidFill>
                   <a:srgbClr val="535C69"/>
                 </a:solidFill>
-                <a:latin typeface="Segoe UI"/>
+                <a:latin typeface="Arial"/>
               </a:rPr>
               <a:t>Бесплатное мобильное приложение: сотрудник подписывает документ со смартфона за пару минут.</a:t>
             </a:r>
@@ -11133,7 +11133,7 @@
                 <a:solidFill>
                   <a:srgbClr val="1E2A38"/>
                 </a:solidFill>
-                <a:latin typeface="Segoe UI"/>
+                <a:latin typeface="Arial"/>
               </a:rPr>
               <a:t>Интеграция с 1С</a:t>
             </a:r>
@@ -11175,7 +11175,7 @@
                 <a:solidFill>
                   <a:srgbClr val="535C69"/>
                 </a:solidFill>
-                <a:latin typeface="Segoe UI"/>
+                <a:latin typeface="Arial"/>
               </a:rPr>
               <a:t>Отправка документов из 1С на подпись и автозаполнение данных сотрудников — без ручного ввода.</a:t>
             </a:r>
@@ -11307,7 +11307,7 @@
                 <a:solidFill>
                   <a:srgbClr val="1E2A38"/>
                 </a:solidFill>
-                <a:latin typeface="Segoe UI"/>
+                <a:latin typeface="Arial"/>
               </a:rPr>
               <a:t>Электронный архив</a:t>
             </a:r>
@@ -11349,7 +11349,7 @@
                 <a:solidFill>
                   <a:srgbClr val="535C69"/>
                 </a:solidFill>
-                <a:latin typeface="Segoe UI"/>
+                <a:latin typeface="Arial"/>
               </a:rPr>
               <a:t>Все документы хранятся в одном месте: даже через 5 лет нужный файл находится в 2 клика.</a:t>
             </a:r>
@@ -11497,7 +11497,7 @@
                 <a:solidFill>
                   <a:srgbClr val="1E2A38"/>
                 </a:solidFill>
-                <a:latin typeface="Segoe UI"/>
+                <a:latin typeface="Arial"/>
               </a:rPr>
               <a:t>Как отправить документ на подпись</a:t>
             </a:r>
@@ -11539,7 +11539,7 @@
                 <a:solidFill>
                   <a:srgbClr val="535C69"/>
                 </a:solidFill>
-                <a:latin typeface="Segoe UI"/>
+                <a:latin typeface="Arial"/>
               </a:rPr>
               <a:t>Четыре шага на стороне HR — и документ уходит сотрудникам</a:t>
             </a:r>
@@ -11627,7 +11627,7 @@
                 <a:solidFill>
                   <a:srgbClr val="FFFFFF"/>
                 </a:solidFill>
-                <a:latin typeface="Segoe UI"/>
+                <a:latin typeface="Arial"/>
               </a:rPr>
               <a:t>S</a:t>
             </a:r>
@@ -11669,7 +11669,7 @@
                 <a:solidFill>
                   <a:srgbClr val="1E2A38"/>
                 </a:solidFill>
-                <a:latin typeface="Segoe UI"/>
+                <a:latin typeface="Arial"/>
               </a:rPr>
               <a:t>smart </a:t>
             </a:r>
@@ -11711,7 +11711,7 @@
                 <a:solidFill>
                   <a:srgbClr val="2FC6F5"/>
                 </a:solidFill>
-                <a:latin typeface="Segoe UI"/>
+                <a:latin typeface="Arial"/>
               </a:rPr>
               <a:t>business</a:t>
             </a:r>
@@ -11753,7 +11753,7 @@
                 <a:solidFill>
                   <a:srgbClr val="535C69"/>
                 </a:solidFill>
-                <a:latin typeface="Segoe UI"/>
+                <a:latin typeface="Arial"/>
               </a:rPr>
               <a:t>05</a:t>
             </a:r>
@@ -11795,7 +11795,7 @@
                 <a:solidFill>
                   <a:srgbClr val="535C69"/>
                 </a:solidFill>
-                <a:latin typeface="Segoe UI"/>
+                <a:latin typeface="Arial"/>
               </a:rPr>
               <a:t>Битрикс24 КЭДО  •  Smart Business — официальный партнёр Битрикс24</a:t>
             </a:r>
@@ -11927,7 +11927,7 @@
                 <a:solidFill>
                   <a:srgbClr val="FFFFFF"/>
                 </a:solidFill>
-                <a:latin typeface="Segoe UI"/>
+                <a:latin typeface="Arial"/>
               </a:rPr>
               <a:t>1</a:t>
             </a:r>
@@ -11969,7 +11969,7 @@
                 <a:solidFill>
                   <a:srgbClr val="1E2A38"/>
                 </a:solidFill>
-                <a:latin typeface="Segoe UI"/>
+                <a:latin typeface="Arial"/>
               </a:rPr>
               <a:t>Подготовьте документ</a:t>
             </a:r>
@@ -12011,7 +12011,7 @@
                 <a:solidFill>
                   <a:srgbClr val="535C69"/>
                 </a:solidFill>
-                <a:latin typeface="Segoe UI"/>
+                <a:latin typeface="Arial"/>
               </a:rPr>
               <a:t>Загрузите файл или создайте его по шаблону — реквизиты заполнятся автоматически.</a:t>
             </a:r>
@@ -12143,7 +12143,7 @@
                 <a:solidFill>
                   <a:srgbClr val="FFFFFF"/>
                 </a:solidFill>
-                <a:latin typeface="Segoe UI"/>
+                <a:latin typeface="Arial"/>
               </a:rPr>
               <a:t>2</a:t>
             </a:r>
@@ -12185,7 +12185,7 @@
                 <a:solidFill>
                   <a:srgbClr val="1E2A38"/>
                 </a:solidFill>
-                <a:latin typeface="Segoe UI"/>
+                <a:latin typeface="Arial"/>
               </a:rPr>
               <a:t>Выберите компанию и представителя</a:t>
             </a:r>
@@ -12227,7 +12227,7 @@
                 <a:solidFill>
                   <a:srgbClr val="535C69"/>
                 </a:solidFill>
-                <a:latin typeface="Segoe UI"/>
+                <a:latin typeface="Arial"/>
               </a:rPr>
               <a:t>Кто подписывает со стороны работодателя (УКЭП).</a:t>
             </a:r>
@@ -12359,7 +12359,7 @@
                 <a:solidFill>
                   <a:srgbClr val="FFFFFF"/>
                 </a:solidFill>
-                <a:latin typeface="Segoe UI"/>
+                <a:latin typeface="Arial"/>
               </a:rPr>
               <a:t>3</a:t>
             </a:r>
@@ -12401,7 +12401,7 @@
                 <a:solidFill>
                   <a:srgbClr val="1E2A38"/>
                 </a:solidFill>
-                <a:latin typeface="Segoe UI"/>
+                <a:latin typeface="Arial"/>
               </a:rPr>
               <a:t>Укажите провайдера подписи</a:t>
             </a:r>
@@ -12443,7 +12443,7 @@
                 <a:solidFill>
                   <a:srgbClr val="535C69"/>
                 </a:solidFill>
-                <a:latin typeface="Segoe UI"/>
+                <a:latin typeface="Arial"/>
               </a:rPr>
               <a:t>Госключ (УНЭП/УКЭП) или внутренний сервис Битрикс24 КЭДО (ПЭП).</a:t>
             </a:r>
@@ -12575,7 +12575,7 @@
                 <a:solidFill>
                   <a:srgbClr val="FFFFFF"/>
                 </a:solidFill>
-                <a:latin typeface="Segoe UI"/>
+                <a:latin typeface="Arial"/>
               </a:rPr>
               <a:t>4</a:t>
             </a:r>
@@ -12617,7 +12617,7 @@
                 <a:solidFill>
                   <a:srgbClr val="1E2A38"/>
                 </a:solidFill>
-                <a:latin typeface="Segoe UI"/>
+                <a:latin typeface="Arial"/>
               </a:rPr>
               <a:t>Выберите сотрудников</a:t>
             </a:r>
@@ -12659,7 +12659,7 @@
                 <a:solidFill>
                   <a:srgbClr val="535C69"/>
                 </a:solidFill>
-                <a:latin typeface="Segoe UI"/>
+                <a:latin typeface="Arial"/>
               </a:rPr>
               <a:t>Одного, отдел или всю компанию — каждый получит уведомление.</a:t>
             </a:r>
@@ -12747,7 +12747,7 @@
                 <a:solidFill>
                   <a:srgbClr val="2FC6F5"/>
                 </a:solidFill>
-                <a:latin typeface="Segoe UI"/>
+                <a:latin typeface="Arial"/>
               </a:rPr>
               <a:t>Что видит сотрудник</a:t>
             </a:r>
@@ -12789,7 +12789,7 @@
                 <a:solidFill>
                   <a:srgbClr val="FFFFFF"/>
                 </a:solidFill>
-                <a:latin typeface="Segoe UI"/>
+                <a:latin typeface="Arial"/>
               </a:rPr>
               <a:t>1.  Уведомление в Битрикс24 о поступившем документе</a:t>
             </a:r>
@@ -12808,7 +12808,7 @@
                 <a:solidFill>
                   <a:srgbClr val="FFFFFF"/>
                 </a:solidFill>
-                <a:latin typeface="Segoe UI"/>
+                <a:latin typeface="Arial"/>
               </a:rPr>
               <a:t>2.  Переход в приложение Госключ на смартфоне</a:t>
             </a:r>
@@ -12827,7 +12827,7 @@
                 <a:solidFill>
                   <a:srgbClr val="FFFFFF"/>
                 </a:solidFill>
-                <a:latin typeface="Segoe UI"/>
+                <a:latin typeface="Arial"/>
               </a:rPr>
               <a:t>3.  Подписание в пару касаний — документ автоматически возвращается в Битрикс24 и попадает в архив</a:t>
             </a:r>
@@ -12975,7 +12975,7 @@
                 <a:solidFill>
                   <a:srgbClr val="1E2A38"/>
                 </a:solidFill>
-                <a:latin typeface="Segoe UI"/>
+                <a:latin typeface="Arial"/>
               </a:rPr>
               <a:t>Электронные подписи и Госключ</a:t>
             </a:r>
@@ -13017,7 +13017,7 @@
                 <a:solidFill>
                   <a:srgbClr val="535C69"/>
                 </a:solidFill>
-                <a:latin typeface="Segoe UI"/>
+                <a:latin typeface="Arial"/>
               </a:rPr>
               <a:t>Каждая сторона подписывает документы так, как требует закон</a:t>
             </a:r>
@@ -13105,7 +13105,7 @@
                 <a:solidFill>
                   <a:srgbClr val="FFFFFF"/>
                 </a:solidFill>
-                <a:latin typeface="Segoe UI"/>
+                <a:latin typeface="Arial"/>
               </a:rPr>
               <a:t>S</a:t>
             </a:r>
@@ -13147,7 +13147,7 @@
                 <a:solidFill>
                   <a:srgbClr val="1E2A38"/>
                 </a:solidFill>
-                <a:latin typeface="Segoe UI"/>
+                <a:latin typeface="Arial"/>
               </a:rPr>
               <a:t>smart </a:t>
             </a:r>
@@ -13189,7 +13189,7 @@
                 <a:solidFill>
                   <a:srgbClr val="2FC6F5"/>
                 </a:solidFill>
-                <a:latin typeface="Segoe UI"/>
+                <a:latin typeface="Arial"/>
               </a:rPr>
               <a:t>business</a:t>
             </a:r>
@@ -13231,7 +13231,7 @@
                 <a:solidFill>
                   <a:srgbClr val="535C69"/>
                 </a:solidFill>
-                <a:latin typeface="Segoe UI"/>
+                <a:latin typeface="Arial"/>
               </a:rPr>
               <a:t>06</a:t>
             </a:r>
@@ -13273,7 +13273,7 @@
                 <a:solidFill>
                   <a:srgbClr val="535C69"/>
                 </a:solidFill>
-                <a:latin typeface="Segoe UI"/>
+                <a:latin typeface="Arial"/>
               </a:rPr>
               <a:t>Битрикс24 КЭДО  •  Smart Business — официальный партнёр Битрикс24</a:t>
             </a:r>
@@ -13405,7 +13405,7 @@
                 <a:solidFill>
                   <a:srgbClr val="1E2A38"/>
                 </a:solidFill>
-                <a:latin typeface="Segoe UI"/>
+                <a:latin typeface="Arial"/>
               </a:rPr>
               <a:t>Работодатель — УКЭП</a:t>
             </a:r>
@@ -13447,7 +13447,7 @@
                 <a:solidFill>
                   <a:srgbClr val="535C69"/>
                 </a:solidFill>
-                <a:latin typeface="Segoe UI"/>
+                <a:latin typeface="Arial"/>
               </a:rPr>
               <a:t>Усиленная квалифицированная электронная подпись. Документы заверяет уполномоченный представитель компании.</a:t>
             </a:r>
@@ -13579,7 +13579,7 @@
                 <a:solidFill>
                   <a:srgbClr val="1E2A38"/>
                 </a:solidFill>
-                <a:latin typeface="Segoe UI"/>
+                <a:latin typeface="Arial"/>
               </a:rPr>
               <a:t>Сотрудник — УНЭП / ПЭП</a:t>
             </a:r>
@@ -13621,7 +13621,7 @@
                 <a:solidFill>
                   <a:srgbClr val="535C69"/>
                 </a:solidFill>
-                <a:latin typeface="Segoe UI"/>
+                <a:latin typeface="Arial"/>
               </a:rPr>
               <a:t>Усиленная неквалифицированная подпись через Госключ или простая электронная подпись через внутренний сервис Битрикс24 КЭДО — в зависимости от типа документа.</a:t>
             </a:r>
@@ -13709,7 +13709,7 @@
                 <a:solidFill>
                   <a:srgbClr val="2FC6F5"/>
                 </a:solidFill>
-                <a:latin typeface="Segoe UI"/>
+                <a:latin typeface="Arial"/>
               </a:rPr>
               <a:t>Госключ</a:t>
             </a:r>
@@ -13751,7 +13751,7 @@
                 <a:solidFill>
                   <a:srgbClr val="FFFFFF"/>
                 </a:solidFill>
-                <a:latin typeface="Segoe UI"/>
+                <a:latin typeface="Arial"/>
               </a:rPr>
               <a:t>•  Бесплатное мобильное приложение Минцифры</a:t>
             </a:r>
@@ -13770,7 +13770,7 @@
                 <a:solidFill>
                   <a:srgbClr val="FFFFFF"/>
                 </a:solidFill>
-                <a:latin typeface="Segoe UI"/>
+                <a:latin typeface="Arial"/>
               </a:rPr>
               <a:t>•  Подпись выпускается онлайн — без визита в удостоверяющий центр</a:t>
             </a:r>
@@ -13789,7 +13789,7 @@
                 <a:solidFill>
                   <a:srgbClr val="FFFFFF"/>
                 </a:solidFill>
-                <a:latin typeface="Segoe UI"/>
+                <a:latin typeface="Arial"/>
               </a:rPr>
               <a:t>•  Нужна только подтверждённая учётная запись на Госуслугах</a:t>
             </a:r>
@@ -13808,7 +13808,7 @@
                 <a:solidFill>
                   <a:srgbClr val="FFFFFF"/>
                 </a:solidFill>
-                <a:latin typeface="Segoe UI"/>
+                <a:latin typeface="Arial"/>
               </a:rPr>
               <a:t>•  Сотрудник подписывает документы со своего смартфона из любой точки</a:t>
             </a:r>
@@ -13827,7 +13827,7 @@
                 <a:solidFill>
                   <a:srgbClr val="9DCF00"/>
                 </a:solidFill>
-                <a:latin typeface="Segoe UI"/>
+                <a:latin typeface="Arial"/>
               </a:rPr>
               <a:t>•  Для сотрудника — 0 рублей</a:t>
             </a:r>
@@ -13975,7 +13975,7 @@
                 <a:solidFill>
                   <a:srgbClr val="1E2A38"/>
                 </a:solidFill>
-                <a:latin typeface="Segoe UI"/>
+                <a:latin typeface="Arial"/>
               </a:rPr>
               <a:t>Интеграция с 1С: без ручного ввода</a:t>
             </a:r>
@@ -14017,7 +14017,7 @@
                 <a:solidFill>
                   <a:srgbClr val="535C69"/>
                 </a:solidFill>
-                <a:latin typeface="Segoe UI"/>
+                <a:latin typeface="Arial"/>
               </a:rPr>
               <a:t>Связка Битрикс24 КЭДО + 1С (в т.ч. 1С:ЗУП) исключает ошибки и двойную работу</a:t>
             </a:r>
@@ -14105,7 +14105,7 @@
                 <a:solidFill>
                   <a:srgbClr val="FFFFFF"/>
                 </a:solidFill>
-                <a:latin typeface="Segoe UI"/>
+                <a:latin typeface="Arial"/>
               </a:rPr>
               <a:t>S</a:t>
             </a:r>
@@ -14147,7 +14147,7 @@
                 <a:solidFill>
                   <a:srgbClr val="1E2A38"/>
                 </a:solidFill>
-                <a:latin typeface="Segoe UI"/>
+                <a:latin typeface="Arial"/>
               </a:rPr>
               <a:t>smart </a:t>
             </a:r>
@@ -14189,7 +14189,7 @@
                 <a:solidFill>
                   <a:srgbClr val="2FC6F5"/>
                 </a:solidFill>
-                <a:latin typeface="Segoe UI"/>
+                <a:latin typeface="Arial"/>
               </a:rPr>
               <a:t>business</a:t>
             </a:r>
@@ -14231,7 +14231,7 @@
                 <a:solidFill>
                   <a:srgbClr val="535C69"/>
                 </a:solidFill>
-                <a:latin typeface="Segoe UI"/>
+                <a:latin typeface="Arial"/>
               </a:rPr>
               <a:t>07</a:t>
             </a:r>
@@ -14273,7 +14273,7 @@
                 <a:solidFill>
                   <a:srgbClr val="535C69"/>
                 </a:solidFill>
-                <a:latin typeface="Segoe UI"/>
+                <a:latin typeface="Arial"/>
               </a:rPr>
               <a:t>Битрикс24 КЭДО  •  Smart Business — официальный партнёр Битрикс24</a:t>
             </a:r>
@@ -14405,7 +14405,7 @@
                 <a:solidFill>
                   <a:srgbClr val="1E2A38"/>
                 </a:solidFill>
-                <a:latin typeface="Segoe UI"/>
+                <a:latin typeface="Arial"/>
               </a:rPr>
               <a:t>Документы из 1С — на подпись</a:t>
             </a:r>
@@ -14447,7 +14447,7 @@
                 <a:solidFill>
                   <a:srgbClr val="535C69"/>
                 </a:solidFill>
-                <a:latin typeface="Segoe UI"/>
+                <a:latin typeface="Arial"/>
               </a:rPr>
               <a:t>Кадровик формирует документ в привычной 1С и отправляет его на подписание в Битрикс24 КЭДО, не выходя из программы.</a:t>
             </a:r>
@@ -14579,7 +14579,7 @@
                 <a:solidFill>
                   <a:srgbClr val="1E2A38"/>
                 </a:solidFill>
-                <a:latin typeface="Segoe UI"/>
+                <a:latin typeface="Arial"/>
               </a:rPr>
               <a:t>Данные сотрудников из 1С</a:t>
             </a:r>
@@ -14621,7 +14621,7 @@
                 <a:solidFill>
                   <a:srgbClr val="535C69"/>
                 </a:solidFill>
-                <a:latin typeface="Segoe UI"/>
+                <a:latin typeface="Arial"/>
               </a:rPr>
               <a:t>Битрикс24 КЭДО заполняет шаблоны данными из 1С: сопоставление сотрудников настраивается один раз.</a:t>
             </a:r>
@@ -14753,7 +14753,7 @@
                 <a:solidFill>
                   <a:srgbClr val="1E2A38"/>
                 </a:solidFill>
-                <a:latin typeface="Segoe UI"/>
+                <a:latin typeface="Arial"/>
               </a:rPr>
               <a:t>Статусы и архив</a:t>
             </a:r>
@@ -14795,7 +14795,7 @@
                 <a:solidFill>
                   <a:srgbClr val="535C69"/>
                 </a:solidFill>
-                <a:latin typeface="Segoe UI"/>
+                <a:latin typeface="Arial"/>
               </a:rPr>
               <a:t>Подписанные документы и статусы синхронизируются: в 1С видно, что подписано, а что ждёт сотрудника.</a:t>
             </a:r>
@@ -14883,7 +14883,7 @@
                 <a:solidFill>
                   <a:srgbClr val="1E2A38"/>
                 </a:solidFill>
-                <a:latin typeface="Segoe UI"/>
+                <a:latin typeface="Arial"/>
               </a:rPr>
               <a:t>Результат: </a:t>
             </a:r>
@@ -14902,7 +14902,7 @@
                 <a:solidFill>
                   <a:srgbClr val="535C69"/>
                 </a:solidFill>
-                <a:latin typeface="Segoe UI"/>
+                <a:latin typeface="Arial"/>
               </a:rPr>
               <a:t>ноль ручного переноса данных между системами, ноль ошибок в реквизитах и датах, единый контур «1С → Битрикс24 → Госключ → архив».</a:t>
             </a:r>
@@ -15050,7 +15050,7 @@
                 <a:solidFill>
                   <a:srgbClr val="1E2A38"/>
                 </a:solidFill>
-                <a:latin typeface="Segoe UI"/>
+                <a:latin typeface="Arial"/>
               </a:rPr>
               <a:t>Шаблоны и комплекты документов</a:t>
             </a:r>
@@ -15092,7 +15092,7 @@
                 <a:solidFill>
                   <a:srgbClr val="535C69"/>
                 </a:solidFill>
-                <a:latin typeface="Segoe UI"/>
+                <a:latin typeface="Arial"/>
               </a:rPr>
               <a:t>Типовые документы создаются за секунды, а не печатаются заново</a:t>
             </a:r>
@@ -15180,7 +15180,7 @@
                 <a:solidFill>
                   <a:srgbClr val="FFFFFF"/>
                 </a:solidFill>
-                <a:latin typeface="Segoe UI"/>
+                <a:latin typeface="Arial"/>
               </a:rPr>
               <a:t>S</a:t>
             </a:r>
@@ -15222,7 +15222,7 @@
                 <a:solidFill>
                   <a:srgbClr val="1E2A38"/>
                 </a:solidFill>
-                <a:latin typeface="Segoe UI"/>
+                <a:latin typeface="Arial"/>
               </a:rPr>
               <a:t>smart </a:t>
             </a:r>
@@ -15264,7 +15264,7 @@
                 <a:solidFill>
                   <a:srgbClr val="2FC6F5"/>
                 </a:solidFill>
-                <a:latin typeface="Segoe UI"/>
+                <a:latin typeface="Arial"/>
               </a:rPr>
               <a:t>business</a:t>
             </a:r>
@@ -15306,7 +15306,7 @@
                 <a:solidFill>
                   <a:srgbClr val="535C69"/>
                 </a:solidFill>
-                <a:latin typeface="Segoe UI"/>
+                <a:latin typeface="Arial"/>
               </a:rPr>
               <a:t>08</a:t>
             </a:r>
@@ -15348,7 +15348,7 @@
                 <a:solidFill>
                   <a:srgbClr val="535C69"/>
                 </a:solidFill>
-                <a:latin typeface="Segoe UI"/>
+                <a:latin typeface="Arial"/>
               </a:rPr>
               <a:t>Битрикс24 КЭДО  •  Smart Business — официальный партнёр Битрикс24</a:t>
             </a:r>
@@ -15434,7 +15434,7 @@
                 <a:solidFill>
                   <a:srgbClr val="1E2A38"/>
                 </a:solidFill>
-                <a:latin typeface="Segoe UI"/>
+                <a:latin typeface="Arial"/>
               </a:rPr>
               <a:t>Свои шаблоны</a:t>
             </a:r>
@@ -15453,7 +15453,7 @@
                 <a:solidFill>
                   <a:srgbClr val="535C69"/>
                 </a:solidFill>
-                <a:latin typeface="Segoe UI"/>
+                <a:latin typeface="Arial"/>
               </a:rPr>
               <a:t> — загрузите трудовой договор, допсоглашение, приказ или заявление компании.</a:t>
             </a:r>
@@ -15539,7 +15539,7 @@
                 <a:solidFill>
                   <a:srgbClr val="1E2A38"/>
                 </a:solidFill>
-                <a:latin typeface="Segoe UI"/>
+                <a:latin typeface="Arial"/>
               </a:rPr>
               <a:t>Автозаполнение</a:t>
             </a:r>
@@ -15558,7 +15558,7 @@
                 <a:solidFill>
                   <a:srgbClr val="535C69"/>
                 </a:solidFill>
-                <a:latin typeface="Segoe UI"/>
+                <a:latin typeface="Arial"/>
               </a:rPr>
               <a:t> — данные компании и сотрудника подставляются из Битрикс24 и 1С.</a:t>
             </a:r>
@@ -15644,7 +15644,7 @@
                 <a:solidFill>
                   <a:srgbClr val="1E2A38"/>
                 </a:solidFill>
-                <a:latin typeface="Segoe UI"/>
+                <a:latin typeface="Arial"/>
               </a:rPr>
               <a:t>Самообслуживание</a:t>
             </a:r>
@@ -15663,7 +15663,7 @@
                 <a:solidFill>
                   <a:srgbClr val="535C69"/>
                 </a:solidFill>
-                <a:latin typeface="Segoe UI"/>
+                <a:latin typeface="Arial"/>
               </a:rPr>
               <a:t> — сотрудник сам формирует заявление на отпуск или командировку по шаблону и отправляет на подпись.</a:t>
             </a:r>
@@ -15749,7 +15749,7 @@
                 <a:solidFill>
                   <a:srgbClr val="1E2A38"/>
                 </a:solidFill>
-                <a:latin typeface="Segoe UI"/>
+                <a:latin typeface="Arial"/>
               </a:rPr>
               <a:t>Подпись ПЭП</a:t>
             </a:r>
@@ -15768,7 +15768,7 @@
                 <a:solidFill>
                   <a:srgbClr val="535C69"/>
                 </a:solidFill>
-                <a:latin typeface="Segoe UI"/>
+                <a:latin typeface="Arial"/>
               </a:rPr>
               <a:t> — типовые заявления подписываются простой электронной подписью прямо в Битрикс24.</a:t>
             </a:r>
@@ -15856,7 +15856,7 @@
                 <a:solidFill>
                   <a:srgbClr val="1E2A38"/>
                 </a:solidFill>
-                <a:latin typeface="Segoe UI"/>
+                <a:latin typeface="Arial"/>
               </a:rPr>
               <a:t>Комплект «Приём сотрудника»</a:t>
             </a:r>
@@ -15942,7 +15942,7 @@
                 <a:solidFill>
                   <a:srgbClr val="FFFFFF"/>
                 </a:solidFill>
-                <a:latin typeface="Segoe UI"/>
+                <a:latin typeface="Arial"/>
               </a:rPr>
               <a:t>✓</a:t>
             </a:r>
@@ -15984,7 +15984,7 @@
                 <a:solidFill>
                   <a:srgbClr val="535C69"/>
                 </a:solidFill>
-                <a:latin typeface="Segoe UI"/>
+                <a:latin typeface="Arial"/>
               </a:rPr>
               <a:t>Трудовой договор</a:t>
             </a:r>
@@ -16070,7 +16070,7 @@
                 <a:solidFill>
                   <a:srgbClr val="FFFFFF"/>
                 </a:solidFill>
-                <a:latin typeface="Segoe UI"/>
+                <a:latin typeface="Arial"/>
               </a:rPr>
               <a:t>✓</a:t>
             </a:r>
@@ -16112,7 +16112,7 @@
                 <a:solidFill>
                   <a:srgbClr val="535C69"/>
                 </a:solidFill>
-                <a:latin typeface="Segoe UI"/>
+                <a:latin typeface="Arial"/>
               </a:rPr>
               <a:t>Согласие на обработку персональных данных</a:t>
             </a:r>
@@ -16198,7 +16198,7 @@
                 <a:solidFill>
                   <a:srgbClr val="FFFFFF"/>
                 </a:solidFill>
-                <a:latin typeface="Segoe UI"/>
+                <a:latin typeface="Arial"/>
               </a:rPr>
               <a:t>✓</a:t>
             </a:r>
@@ -16240,7 +16240,7 @@
                 <a:solidFill>
                   <a:srgbClr val="535C69"/>
                 </a:solidFill>
-                <a:latin typeface="Segoe UI"/>
+                <a:latin typeface="Arial"/>
               </a:rPr>
               <a:t>Положение о коммерческой тайне (NDA)</a:t>
             </a:r>
@@ -16326,7 +16326,7 @@
                 <a:solidFill>
                   <a:srgbClr val="FFFFFF"/>
                 </a:solidFill>
-                <a:latin typeface="Segoe UI"/>
+                <a:latin typeface="Arial"/>
               </a:rPr>
               <a:t>✓</a:t>
             </a:r>
@@ -16368,7 +16368,7 @@
                 <a:solidFill>
                   <a:srgbClr val="535C69"/>
                 </a:solidFill>
-                <a:latin typeface="Segoe UI"/>
+                <a:latin typeface="Arial"/>
               </a:rPr>
               <a:t>Ознакомление с ЛНА и должностной инструкцией</a:t>
             </a:r>
@@ -16410,7 +16410,7 @@
                 <a:solidFill>
                   <a:srgbClr val="0075FF"/>
                 </a:solidFill>
-                <a:latin typeface="Segoe UI"/>
+                <a:latin typeface="Arial"/>
               </a:rPr>
               <a:t>Весь комплект уходит сотруднику одним кликом</a:t>
             </a:r>
@@ -16558,7 +16558,7 @@
                 <a:solidFill>
                   <a:srgbClr val="1E2A38"/>
                 </a:solidFill>
-                <a:latin typeface="Segoe UI"/>
+                <a:latin typeface="Arial"/>
               </a:rPr>
               <a:t>Что остаётся на бумаге</a:t>
             </a:r>
@@ -16600,7 +16600,7 @@
                 <a:solidFill>
                   <a:srgbClr val="535C69"/>
                 </a:solidFill>
-                <a:latin typeface="Segoe UI"/>
+                <a:latin typeface="Arial"/>
               </a:rPr>
               <a:t>Закон (ст. 22.1 ТК РФ) оставляет несколько исключений — важно учесть при переходе</a:t>
             </a:r>
@@ -16688,7 +16688,7 @@
                 <a:solidFill>
                   <a:srgbClr val="FFFFFF"/>
                 </a:solidFill>
-                <a:latin typeface="Segoe UI"/>
+                <a:latin typeface="Arial"/>
               </a:rPr>
               <a:t>S</a:t>
             </a:r>
@@ -16730,7 +16730,7 @@
                 <a:solidFill>
                   <a:srgbClr val="1E2A38"/>
                 </a:solidFill>
-                <a:latin typeface="Segoe UI"/>
+                <a:latin typeface="Arial"/>
               </a:rPr>
               <a:t>smart </a:t>
             </a:r>
@@ -16772,7 +16772,7 @@
                 <a:solidFill>
                   <a:srgbClr val="2FC6F5"/>
                 </a:solidFill>
-                <a:latin typeface="Segoe UI"/>
+                <a:latin typeface="Arial"/>
               </a:rPr>
               <a:t>business</a:t>
             </a:r>
@@ -16814,7 +16814,7 @@
                 <a:solidFill>
                   <a:srgbClr val="535C69"/>
                 </a:solidFill>
-                <a:latin typeface="Segoe UI"/>
+                <a:latin typeface="Arial"/>
               </a:rPr>
               <a:t>09</a:t>
             </a:r>
@@ -16856,7 +16856,7 @@
                 <a:solidFill>
                   <a:srgbClr val="535C69"/>
                 </a:solidFill>
-                <a:latin typeface="Segoe UI"/>
+                <a:latin typeface="Arial"/>
               </a:rPr>
               <a:t>Битрикс24 КЭДО  •  Smart Business — официальный партнёр Битрикс24</a:t>
             </a:r>
@@ -16988,7 +16988,7 @@
                 <a:solidFill>
                   <a:srgbClr val="1E2A38"/>
                 </a:solidFill>
-                <a:latin typeface="Segoe UI"/>
+                <a:latin typeface="Arial"/>
               </a:rPr>
               <a:t>Трудовые книжки и сведения о трудовой деятельности (СТД-Р)</a:t>
             </a:r>
@@ -17120,7 +17120,7 @@
                 <a:solidFill>
                   <a:srgbClr val="1E2A38"/>
                 </a:solidFill>
-                <a:latin typeface="Segoe UI"/>
+                <a:latin typeface="Arial"/>
               </a:rPr>
               <a:t>Акты о несчастном случае на производстве</a:t>
             </a:r>
@@ -17252,7 +17252,7 @@
                 <a:solidFill>
                   <a:srgbClr val="1E2A38"/>
                 </a:solidFill>
-                <a:latin typeface="Segoe UI"/>
+                <a:latin typeface="Arial"/>
               </a:rPr>
               <a:t>Приказы (распоряжения) об увольнении</a:t>
             </a:r>
@@ -17384,7 +17384,7 @@
                 <a:solidFill>
                   <a:srgbClr val="1E2A38"/>
                 </a:solidFill>
-                <a:latin typeface="Segoe UI"/>
+                <a:latin typeface="Arial"/>
               </a:rPr>
               <a:t>Документы о прохождении инструктажей по охране труда</a:t>
             </a:r>
@@ -17516,7 +17516,7 @@
                 <a:solidFill>
                   <a:srgbClr val="1E2A38"/>
                 </a:solidFill>
-                <a:latin typeface="Segoe UI"/>
+                <a:latin typeface="Arial"/>
               </a:rPr>
               <a:t>Согласие сотрудника обязательно</a:t>
             </a:r>
@@ -17558,7 +17558,7 @@
                 <a:solidFill>
                   <a:srgbClr val="535C69"/>
                 </a:solidFill>
-                <a:latin typeface="Segoe UI"/>
+                <a:latin typeface="Arial"/>
               </a:rPr>
               <a:t>Переход на КЭДО возможен только с письменного согласия работника. Отказ — не основание для увольнения или отказа в приёме на работу.</a:t>
             </a:r>
@@ -17690,7 +17690,7 @@
                 <a:solidFill>
                   <a:srgbClr val="1E2A38"/>
                 </a:solidFill>
-                <a:latin typeface="Segoe UI"/>
+                <a:latin typeface="Arial"/>
               </a:rPr>
               <a:t>Исключение для новичков</a:t>
             </a:r>
@@ -17732,7 +17732,7 @@
                 <a:solidFill>
                   <a:srgbClr val="535C69"/>
                 </a:solidFill>
-                <a:latin typeface="Segoe UI"/>
+                <a:latin typeface="Arial"/>
               </a:rPr>
               <a:t>Сотрудников, принятых после 31.12.2021 и не имеющих трудового стажа, можно переводить на КЭДО без отдельного согласия.</a:t>
             </a:r>

</xml_diff>